<commit_message>
Refactor presentation slide deck design and bold text highlights
</commit_message>
<xml_diff>
--- a/reports/Bluestock_MF_Presentation.pptx
+++ b/reports/Bluestock_MF_Presentation.pptx
@@ -1,22 +1,22 @@
 
 <file path=ppt/presentation.xml><?xml version="1.0" encoding="utf-8"?>
-<p:presentation xmlns:a="http://schemas.openxmlformats.org/drawingml/2006/main" xmlns:r="http://schemas.openxmlformats.org/officeDocument/2006/relationships" xmlns:p="http://schemas.openxmlformats.org/presentationml/2006/main" saveSubsetFonts="1" autoCompressPictures="0">
+<p:presentation xmlns:a="http://schemas.openxmlformats.org/drawingml/2006/main" xmlns:r="http://schemas.openxmlformats.org/officeDocument/2006/relationships" xmlns:p="http://schemas.openxmlformats.org/presentationml/2006/main" autoCompressPictures="0">
   <p:sldMasterIdLst>
     <p:sldMasterId id="2147483648" r:id="rId1"/>
   </p:sldMasterIdLst>
   <p:sldIdLst>
-    <p:sldId id="256" r:id="rId7"/>
-    <p:sldId id="257" r:id="rId8"/>
-    <p:sldId id="258" r:id="rId9"/>
-    <p:sldId id="259" r:id="rId10"/>
-    <p:sldId id="260" r:id="rId11"/>
-    <p:sldId id="261" r:id="rId12"/>
-    <p:sldId id="262" r:id="rId13"/>
-    <p:sldId id="263" r:id="rId14"/>
-    <p:sldId id="264" r:id="rId15"/>
-    <p:sldId id="265" r:id="rId16"/>
-    <p:sldId id="266" r:id="rId17"/>
-    <p:sldId id="267" r:id="rId18"/>
+    <p:sldId id="256" r:id="rId3"/>
+    <p:sldId id="257" r:id="rId4"/>
+    <p:sldId id="258" r:id="rId5"/>
+    <p:sldId id="259" r:id="rId6"/>
+    <p:sldId id="260" r:id="rId7"/>
+    <p:sldId id="261" r:id="rId8"/>
+    <p:sldId id="262" r:id="rId9"/>
+    <p:sldId id="263" r:id="rId10"/>
+    <p:sldId id="264" r:id="rId11"/>
+    <p:sldId id="265" r:id="rId12"/>
+    <p:sldId id="266" r:id="rId13"/>
+    <p:sldId id="267" r:id="rId14"/>
   </p:sldIdLst>
   <p:sldSz cx="9144000" cy="5143500" type="screen4x3"/>
   <p:notesSz cx="6858000" cy="9144000"/>
@@ -115,6 +115,22 @@
       </a:defRPr>
     </a:lvl9pPr>
   </p:defaultTextStyle>
+  <p:extLst>
+    <p:ext uri="{EFAFB233-063F-42B5-8137-9DF3F51BA10A}">
+      <p15:sldGuideLst xmlns:p15="http://schemas.microsoft.com/office/powerpoint/2012/main">
+        <p15:guide id="1" orient="horz" pos="2160" userDrawn="1">
+          <p15:clr>
+            <a:srgbClr val="A4A3A4"/>
+          </p15:clr>
+        </p15:guide>
+        <p15:guide id="2" pos="2880" userDrawn="1">
+          <p15:clr>
+            <a:srgbClr val="A4A3A4"/>
+          </p15:clr>
+        </p15:guide>
+      </p15:sldGuideLst>
+    </p:ext>
+  </p:extLst>
 </p:presentation>
 </file>
 
@@ -299,7 +315,6 @@
           <a:p>
             <a:fld id="{5BCAD085-E8A6-8845-BD4E-CB4CCA059FC4}" type="datetimeFigureOut">
               <a:rPr lang="en-US" smtClean="0"/>
-              <a:t>1/27/13</a:t>
             </a:fld>
             <a:endParaRPr lang="en-US"/>
           </a:p>
@@ -341,18 +356,12 @@
           <a:p>
             <a:fld id="{C1FF6DA9-008F-8B48-92A6-B652298478BF}" type="slidenum">
               <a:rPr lang="en-US" smtClean="0"/>
-              <a:t>‹#›</a:t>
             </a:fld>
             <a:endParaRPr lang="en-US"/>
           </a:p>
         </p:txBody>
       </p:sp>
     </p:spTree>
-    <p:extLst>
-      <p:ext uri="{BB962C8B-B14F-4D97-AF65-F5344CB8AC3E}">
-        <p14:creationId xmlns:p14="http://schemas.microsoft.com/office/powerpoint/2010/main" val="3168075583"/>
-      </p:ext>
-    </p:extLst>
   </p:cSld>
   <p:clrMapOvr>
     <a:masterClrMapping/>
@@ -420,6 +429,7 @@
               <a:rPr lang="en-US" smtClean="0"/>
               <a:t>Click to edit Master text styles</a:t>
             </a:r>
+            <a:endParaRPr lang="en-US" smtClean="0"/>
           </a:p>
           <a:p>
             <a:pPr lvl="1"/>
@@ -427,6 +437,7 @@
               <a:rPr lang="en-US" smtClean="0"/>
               <a:t>Second level</a:t>
             </a:r>
+            <a:endParaRPr lang="en-US" smtClean="0"/>
           </a:p>
           <a:p>
             <a:pPr lvl="2"/>
@@ -434,6 +445,7 @@
               <a:rPr lang="en-US" smtClean="0"/>
               <a:t>Third level</a:t>
             </a:r>
+            <a:endParaRPr lang="en-US" smtClean="0"/>
           </a:p>
           <a:p>
             <a:pPr lvl="3"/>
@@ -441,6 +453,7 @@
               <a:rPr lang="en-US" smtClean="0"/>
               <a:t>Fourth level</a:t>
             </a:r>
+            <a:endParaRPr lang="en-US" smtClean="0"/>
           </a:p>
           <a:p>
             <a:pPr lvl="4"/>
@@ -469,7 +482,6 @@
           <a:p>
             <a:fld id="{5BCAD085-E8A6-8845-BD4E-CB4CCA059FC4}" type="datetimeFigureOut">
               <a:rPr lang="en-US" smtClean="0"/>
-              <a:t>1/27/13</a:t>
             </a:fld>
             <a:endParaRPr lang="en-US"/>
           </a:p>
@@ -511,18 +523,12 @@
           <a:p>
             <a:fld id="{C1FF6DA9-008F-8B48-92A6-B652298478BF}" type="slidenum">
               <a:rPr lang="en-US" smtClean="0"/>
-              <a:t>‹#›</a:t>
             </a:fld>
             <a:endParaRPr lang="en-US"/>
           </a:p>
         </p:txBody>
       </p:sp>
     </p:spTree>
-    <p:extLst>
-      <p:ext uri="{BB962C8B-B14F-4D97-AF65-F5344CB8AC3E}">
-        <p14:creationId xmlns:p14="http://schemas.microsoft.com/office/powerpoint/2010/main" val="2910927964"/>
-      </p:ext>
-    </p:extLst>
   </p:cSld>
   <p:clrMapOvr>
     <a:masterClrMapping/>
@@ -600,6 +606,7 @@
               <a:rPr lang="en-US" smtClean="0"/>
               <a:t>Click to edit Master text styles</a:t>
             </a:r>
+            <a:endParaRPr lang="en-US" smtClean="0"/>
           </a:p>
           <a:p>
             <a:pPr lvl="1"/>
@@ -607,6 +614,7 @@
               <a:rPr lang="en-US" smtClean="0"/>
               <a:t>Second level</a:t>
             </a:r>
+            <a:endParaRPr lang="en-US" smtClean="0"/>
           </a:p>
           <a:p>
             <a:pPr lvl="2"/>
@@ -614,6 +622,7 @@
               <a:rPr lang="en-US" smtClean="0"/>
               <a:t>Third level</a:t>
             </a:r>
+            <a:endParaRPr lang="en-US" smtClean="0"/>
           </a:p>
           <a:p>
             <a:pPr lvl="3"/>
@@ -621,6 +630,7 @@
               <a:rPr lang="en-US" smtClean="0"/>
               <a:t>Fourth level</a:t>
             </a:r>
+            <a:endParaRPr lang="en-US" smtClean="0"/>
           </a:p>
           <a:p>
             <a:pPr lvl="4"/>
@@ -649,7 +659,6 @@
           <a:p>
             <a:fld id="{5BCAD085-E8A6-8845-BD4E-CB4CCA059FC4}" type="datetimeFigureOut">
               <a:rPr lang="en-US" smtClean="0"/>
-              <a:t>1/27/13</a:t>
             </a:fld>
             <a:endParaRPr lang="en-US"/>
           </a:p>
@@ -691,18 +700,12 @@
           <a:p>
             <a:fld id="{C1FF6DA9-008F-8B48-92A6-B652298478BF}" type="slidenum">
               <a:rPr lang="en-US" smtClean="0"/>
-              <a:t>‹#›</a:t>
             </a:fld>
             <a:endParaRPr lang="en-US"/>
           </a:p>
         </p:txBody>
       </p:sp>
     </p:spTree>
-    <p:extLst>
-      <p:ext uri="{BB962C8B-B14F-4D97-AF65-F5344CB8AC3E}">
-        <p14:creationId xmlns:p14="http://schemas.microsoft.com/office/powerpoint/2010/main" val="3612223792"/>
-      </p:ext>
-    </p:extLst>
   </p:cSld>
   <p:clrMapOvr>
     <a:masterClrMapping/>
@@ -770,6 +773,7 @@
               <a:rPr lang="en-US" smtClean="0"/>
               <a:t>Click to edit Master text styles</a:t>
             </a:r>
+            <a:endParaRPr lang="en-US" smtClean="0"/>
           </a:p>
           <a:p>
             <a:pPr lvl="1"/>
@@ -777,6 +781,7 @@
               <a:rPr lang="en-US" smtClean="0"/>
               <a:t>Second level</a:t>
             </a:r>
+            <a:endParaRPr lang="en-US" smtClean="0"/>
           </a:p>
           <a:p>
             <a:pPr lvl="2"/>
@@ -784,6 +789,7 @@
               <a:rPr lang="en-US" smtClean="0"/>
               <a:t>Third level</a:t>
             </a:r>
+            <a:endParaRPr lang="en-US" smtClean="0"/>
           </a:p>
           <a:p>
             <a:pPr lvl="3"/>
@@ -791,6 +797,7 @@
               <a:rPr lang="en-US" smtClean="0"/>
               <a:t>Fourth level</a:t>
             </a:r>
+            <a:endParaRPr lang="en-US" smtClean="0"/>
           </a:p>
           <a:p>
             <a:pPr lvl="4"/>
@@ -819,7 +826,6 @@
           <a:p>
             <a:fld id="{5BCAD085-E8A6-8845-BD4E-CB4CCA059FC4}" type="datetimeFigureOut">
               <a:rPr lang="en-US" smtClean="0"/>
-              <a:t>1/27/13</a:t>
             </a:fld>
             <a:endParaRPr lang="en-US"/>
           </a:p>
@@ -861,18 +867,12 @@
           <a:p>
             <a:fld id="{C1FF6DA9-008F-8B48-92A6-B652298478BF}" type="slidenum">
               <a:rPr lang="en-US" smtClean="0"/>
-              <a:t>‹#›</a:t>
             </a:fld>
             <a:endParaRPr lang="en-US"/>
           </a:p>
         </p:txBody>
       </p:sp>
     </p:spTree>
-    <p:extLst>
-      <p:ext uri="{BB962C8B-B14F-4D97-AF65-F5344CB8AC3E}">
-        <p14:creationId xmlns:p14="http://schemas.microsoft.com/office/powerpoint/2010/main" val="2614314258"/>
-      </p:ext>
-    </p:extLst>
   </p:cSld>
   <p:clrMapOvr>
     <a:masterClrMapping/>
@@ -1045,6 +1045,7 @@
               <a:rPr lang="en-US" smtClean="0"/>
               <a:t>Click to edit Master text styles</a:t>
             </a:r>
+            <a:endParaRPr lang="en-US" smtClean="0"/>
           </a:p>
         </p:txBody>
       </p:sp>
@@ -1065,7 +1066,6 @@
           <a:p>
             <a:fld id="{5BCAD085-E8A6-8845-BD4E-CB4CCA059FC4}" type="datetimeFigureOut">
               <a:rPr lang="en-US" smtClean="0"/>
-              <a:t>1/27/13</a:t>
             </a:fld>
             <a:endParaRPr lang="en-US"/>
           </a:p>
@@ -1107,18 +1107,12 @@
           <a:p>
             <a:fld id="{C1FF6DA9-008F-8B48-92A6-B652298478BF}" type="slidenum">
               <a:rPr lang="en-US" smtClean="0"/>
-              <a:t>‹#›</a:t>
             </a:fld>
             <a:endParaRPr lang="en-US"/>
           </a:p>
         </p:txBody>
       </p:sp>
     </p:spTree>
-    <p:extLst>
-      <p:ext uri="{BB962C8B-B14F-4D97-AF65-F5344CB8AC3E}">
-        <p14:creationId xmlns:p14="http://schemas.microsoft.com/office/powerpoint/2010/main" val="960648375"/>
-      </p:ext>
-    </p:extLst>
   </p:cSld>
   <p:clrMapOvr>
     <a:masterClrMapping/>
@@ -1219,6 +1213,7 @@
               <a:rPr lang="en-US" smtClean="0"/>
               <a:t>Click to edit Master text styles</a:t>
             </a:r>
+            <a:endParaRPr lang="en-US" smtClean="0"/>
           </a:p>
           <a:p>
             <a:pPr lvl="1"/>
@@ -1226,6 +1221,7 @@
               <a:rPr lang="en-US" smtClean="0"/>
               <a:t>Second level</a:t>
             </a:r>
+            <a:endParaRPr lang="en-US" smtClean="0"/>
           </a:p>
           <a:p>
             <a:pPr lvl="2"/>
@@ -1233,6 +1229,7 @@
               <a:rPr lang="en-US" smtClean="0"/>
               <a:t>Third level</a:t>
             </a:r>
+            <a:endParaRPr lang="en-US" smtClean="0"/>
           </a:p>
           <a:p>
             <a:pPr lvl="3"/>
@@ -1240,6 +1237,7 @@
               <a:rPr lang="en-US" smtClean="0"/>
               <a:t>Fourth level</a:t>
             </a:r>
+            <a:endParaRPr lang="en-US" smtClean="0"/>
           </a:p>
           <a:p>
             <a:pPr lvl="4"/>
@@ -1304,6 +1302,7 @@
               <a:rPr lang="en-US" smtClean="0"/>
               <a:t>Click to edit Master text styles</a:t>
             </a:r>
+            <a:endParaRPr lang="en-US" smtClean="0"/>
           </a:p>
           <a:p>
             <a:pPr lvl="1"/>
@@ -1311,6 +1310,7 @@
               <a:rPr lang="en-US" smtClean="0"/>
               <a:t>Second level</a:t>
             </a:r>
+            <a:endParaRPr lang="en-US" smtClean="0"/>
           </a:p>
           <a:p>
             <a:pPr lvl="2"/>
@@ -1318,6 +1318,7 @@
               <a:rPr lang="en-US" smtClean="0"/>
               <a:t>Third level</a:t>
             </a:r>
+            <a:endParaRPr lang="en-US" smtClean="0"/>
           </a:p>
           <a:p>
             <a:pPr lvl="3"/>
@@ -1325,6 +1326,7 @@
               <a:rPr lang="en-US" smtClean="0"/>
               <a:t>Fourth level</a:t>
             </a:r>
+            <a:endParaRPr lang="en-US" smtClean="0"/>
           </a:p>
           <a:p>
             <a:pPr lvl="4"/>
@@ -1353,7 +1355,6 @@
           <a:p>
             <a:fld id="{5BCAD085-E8A6-8845-BD4E-CB4CCA059FC4}" type="datetimeFigureOut">
               <a:rPr lang="en-US" smtClean="0"/>
-              <a:t>1/27/13</a:t>
             </a:fld>
             <a:endParaRPr lang="en-US"/>
           </a:p>
@@ -1395,18 +1396,12 @@
           <a:p>
             <a:fld id="{C1FF6DA9-008F-8B48-92A6-B652298478BF}" type="slidenum">
               <a:rPr lang="en-US" smtClean="0"/>
-              <a:t>‹#›</a:t>
             </a:fld>
             <a:endParaRPr lang="en-US"/>
           </a:p>
         </p:txBody>
       </p:sp>
     </p:spTree>
-    <p:extLst>
-      <p:ext uri="{BB962C8B-B14F-4D97-AF65-F5344CB8AC3E}">
-        <p14:creationId xmlns:p14="http://schemas.microsoft.com/office/powerpoint/2010/main" val="2782244947"/>
-      </p:ext>
-    </p:extLst>
   </p:cSld>
   <p:clrMapOvr>
     <a:masterClrMapping/>
@@ -1520,6 +1515,7 @@
               <a:rPr lang="en-US" smtClean="0"/>
               <a:t>Click to edit Master text styles</a:t>
             </a:r>
+            <a:endParaRPr lang="en-US" smtClean="0"/>
           </a:p>
         </p:txBody>
       </p:sp>
@@ -1576,6 +1572,7 @@
               <a:rPr lang="en-US" smtClean="0"/>
               <a:t>Click to edit Master text styles</a:t>
             </a:r>
+            <a:endParaRPr lang="en-US" smtClean="0"/>
           </a:p>
           <a:p>
             <a:pPr lvl="1"/>
@@ -1583,6 +1580,7 @@
               <a:rPr lang="en-US" smtClean="0"/>
               <a:t>Second level</a:t>
             </a:r>
+            <a:endParaRPr lang="en-US" smtClean="0"/>
           </a:p>
           <a:p>
             <a:pPr lvl="2"/>
@@ -1590,6 +1588,7 @@
               <a:rPr lang="en-US" smtClean="0"/>
               <a:t>Third level</a:t>
             </a:r>
+            <a:endParaRPr lang="en-US" smtClean="0"/>
           </a:p>
           <a:p>
             <a:pPr lvl="3"/>
@@ -1597,6 +1596,7 @@
               <a:rPr lang="en-US" smtClean="0"/>
               <a:t>Fourth level</a:t>
             </a:r>
+            <a:endParaRPr lang="en-US" smtClean="0"/>
           </a:p>
           <a:p>
             <a:pPr lvl="4"/>
@@ -1670,6 +1670,7 @@
               <a:rPr lang="en-US" smtClean="0"/>
               <a:t>Click to edit Master text styles</a:t>
             </a:r>
+            <a:endParaRPr lang="en-US" smtClean="0"/>
           </a:p>
         </p:txBody>
       </p:sp>
@@ -1726,6 +1727,7 @@
               <a:rPr lang="en-US" smtClean="0"/>
               <a:t>Click to edit Master text styles</a:t>
             </a:r>
+            <a:endParaRPr lang="en-US" smtClean="0"/>
           </a:p>
           <a:p>
             <a:pPr lvl="1"/>
@@ -1733,6 +1735,7 @@
               <a:rPr lang="en-US" smtClean="0"/>
               <a:t>Second level</a:t>
             </a:r>
+            <a:endParaRPr lang="en-US" smtClean="0"/>
           </a:p>
           <a:p>
             <a:pPr lvl="2"/>
@@ -1740,6 +1743,7 @@
               <a:rPr lang="en-US" smtClean="0"/>
               <a:t>Third level</a:t>
             </a:r>
+            <a:endParaRPr lang="en-US" smtClean="0"/>
           </a:p>
           <a:p>
             <a:pPr lvl="3"/>
@@ -1747,6 +1751,7 @@
               <a:rPr lang="en-US" smtClean="0"/>
               <a:t>Fourth level</a:t>
             </a:r>
+            <a:endParaRPr lang="en-US" smtClean="0"/>
           </a:p>
           <a:p>
             <a:pPr lvl="4"/>
@@ -1775,7 +1780,6 @@
           <a:p>
             <a:fld id="{5BCAD085-E8A6-8845-BD4E-CB4CCA059FC4}" type="datetimeFigureOut">
               <a:rPr lang="en-US" smtClean="0"/>
-              <a:t>1/27/13</a:t>
             </a:fld>
             <a:endParaRPr lang="en-US"/>
           </a:p>
@@ -1817,18 +1821,12 @@
           <a:p>
             <a:fld id="{C1FF6DA9-008F-8B48-92A6-B652298478BF}" type="slidenum">
               <a:rPr lang="en-US" smtClean="0"/>
-              <a:t>‹#›</a:t>
             </a:fld>
             <a:endParaRPr lang="en-US"/>
           </a:p>
         </p:txBody>
       </p:sp>
     </p:spTree>
-    <p:extLst>
-      <p:ext uri="{BB962C8B-B14F-4D97-AF65-F5344CB8AC3E}">
-        <p14:creationId xmlns:p14="http://schemas.microsoft.com/office/powerpoint/2010/main" val="990158736"/>
-      </p:ext>
-    </p:extLst>
   </p:cSld>
   <p:clrMapOvr>
     <a:masterClrMapping/>
@@ -1893,7 +1891,6 @@
           <a:p>
             <a:fld id="{5BCAD085-E8A6-8845-BD4E-CB4CCA059FC4}" type="datetimeFigureOut">
               <a:rPr lang="en-US" smtClean="0"/>
-              <a:t>1/27/13</a:t>
             </a:fld>
             <a:endParaRPr lang="en-US"/>
           </a:p>
@@ -1935,18 +1932,12 @@
           <a:p>
             <a:fld id="{C1FF6DA9-008F-8B48-92A6-B652298478BF}" type="slidenum">
               <a:rPr lang="en-US" smtClean="0"/>
-              <a:t>‹#›</a:t>
             </a:fld>
             <a:endParaRPr lang="en-US"/>
           </a:p>
         </p:txBody>
       </p:sp>
     </p:spTree>
-    <p:extLst>
-      <p:ext uri="{BB962C8B-B14F-4D97-AF65-F5344CB8AC3E}">
-        <p14:creationId xmlns:p14="http://schemas.microsoft.com/office/powerpoint/2010/main" val="727027711"/>
-      </p:ext>
-    </p:extLst>
   </p:cSld>
   <p:clrMapOvr>
     <a:masterClrMapping/>
@@ -1988,7 +1979,6 @@
           <a:p>
             <a:fld id="{5BCAD085-E8A6-8845-BD4E-CB4CCA059FC4}" type="datetimeFigureOut">
               <a:rPr lang="en-US" smtClean="0"/>
-              <a:t>1/27/13</a:t>
             </a:fld>
             <a:endParaRPr lang="en-US"/>
           </a:p>
@@ -2030,18 +2020,12 @@
           <a:p>
             <a:fld id="{C1FF6DA9-008F-8B48-92A6-B652298478BF}" type="slidenum">
               <a:rPr lang="en-US" smtClean="0"/>
-              <a:t>‹#›</a:t>
             </a:fld>
             <a:endParaRPr lang="en-US"/>
           </a:p>
         </p:txBody>
       </p:sp>
     </p:spTree>
-    <p:extLst>
-      <p:ext uri="{BB962C8B-B14F-4D97-AF65-F5344CB8AC3E}">
-        <p14:creationId xmlns:p14="http://schemas.microsoft.com/office/powerpoint/2010/main" val="1212999818"/>
-      </p:ext>
-    </p:extLst>
   </p:cSld>
   <p:clrMapOvr>
     <a:masterClrMapping/>
@@ -2151,6 +2135,7 @@
               <a:rPr lang="en-US" smtClean="0"/>
               <a:t>Click to edit Master text styles</a:t>
             </a:r>
+            <a:endParaRPr lang="en-US" smtClean="0"/>
           </a:p>
           <a:p>
             <a:pPr lvl="1"/>
@@ -2158,6 +2143,7 @@
               <a:rPr lang="en-US" smtClean="0"/>
               <a:t>Second level</a:t>
             </a:r>
+            <a:endParaRPr lang="en-US" smtClean="0"/>
           </a:p>
           <a:p>
             <a:pPr lvl="2"/>
@@ -2165,6 +2151,7 @@
               <a:rPr lang="en-US" smtClean="0"/>
               <a:t>Third level</a:t>
             </a:r>
+            <a:endParaRPr lang="en-US" smtClean="0"/>
           </a:p>
           <a:p>
             <a:pPr lvl="3"/>
@@ -2172,6 +2159,7 @@
               <a:rPr lang="en-US" smtClean="0"/>
               <a:t>Fourth level</a:t>
             </a:r>
+            <a:endParaRPr lang="en-US" smtClean="0"/>
           </a:p>
           <a:p>
             <a:pPr lvl="4"/>
@@ -2245,6 +2233,7 @@
               <a:rPr lang="en-US" smtClean="0"/>
               <a:t>Click to edit Master text styles</a:t>
             </a:r>
+            <a:endParaRPr lang="en-US" smtClean="0"/>
           </a:p>
         </p:txBody>
       </p:sp>
@@ -2265,7 +2254,6 @@
           <a:p>
             <a:fld id="{5BCAD085-E8A6-8845-BD4E-CB4CCA059FC4}" type="datetimeFigureOut">
               <a:rPr lang="en-US" smtClean="0"/>
-              <a:t>1/27/13</a:t>
             </a:fld>
             <a:endParaRPr lang="en-US"/>
           </a:p>
@@ -2307,18 +2295,12 @@
           <a:p>
             <a:fld id="{C1FF6DA9-008F-8B48-92A6-B652298478BF}" type="slidenum">
               <a:rPr lang="en-US" smtClean="0"/>
-              <a:t>‹#›</a:t>
             </a:fld>
             <a:endParaRPr lang="en-US"/>
           </a:p>
         </p:txBody>
       </p:sp>
     </p:spTree>
-    <p:extLst>
-      <p:ext uri="{BB962C8B-B14F-4D97-AF65-F5344CB8AC3E}">
-        <p14:creationId xmlns:p14="http://schemas.microsoft.com/office/powerpoint/2010/main" val="1840726560"/>
-      </p:ext>
-    </p:extLst>
   </p:cSld>
   <p:clrMapOvr>
     <a:masterClrMapping/>
@@ -2498,6 +2480,7 @@
               <a:rPr lang="en-US" smtClean="0"/>
               <a:t>Click to edit Master text styles</a:t>
             </a:r>
+            <a:endParaRPr lang="en-US" smtClean="0"/>
           </a:p>
         </p:txBody>
       </p:sp>
@@ -2518,7 +2501,6 @@
           <a:p>
             <a:fld id="{5BCAD085-E8A6-8845-BD4E-CB4CCA059FC4}" type="datetimeFigureOut">
               <a:rPr lang="en-US" smtClean="0"/>
-              <a:t>1/27/13</a:t>
             </a:fld>
             <a:endParaRPr lang="en-US"/>
           </a:p>
@@ -2560,18 +2542,12 @@
           <a:p>
             <a:fld id="{C1FF6DA9-008F-8B48-92A6-B652298478BF}" type="slidenum">
               <a:rPr lang="en-US" smtClean="0"/>
-              <a:t>‹#›</a:t>
             </a:fld>
             <a:endParaRPr lang="en-US"/>
           </a:p>
         </p:txBody>
       </p:sp>
     </p:spTree>
-    <p:extLst>
-      <p:ext uri="{BB962C8B-B14F-4D97-AF65-F5344CB8AC3E}">
-        <p14:creationId xmlns:p14="http://schemas.microsoft.com/office/powerpoint/2010/main" val="3889236939"/>
-      </p:ext>
-    </p:extLst>
   </p:cSld>
   <p:clrMapOvr>
     <a:masterClrMapping/>
@@ -2664,6 +2640,7 @@
               <a:rPr lang="en-US" smtClean="0"/>
               <a:t>Click to edit Master text styles</a:t>
             </a:r>
+            <a:endParaRPr lang="en-US" smtClean="0"/>
           </a:p>
           <a:p>
             <a:pPr lvl="1"/>
@@ -2671,6 +2648,7 @@
               <a:rPr lang="en-US" smtClean="0"/>
               <a:t>Second level</a:t>
             </a:r>
+            <a:endParaRPr lang="en-US" smtClean="0"/>
           </a:p>
           <a:p>
             <a:pPr lvl="2"/>
@@ -2678,6 +2656,7 @@
               <a:rPr lang="en-US" smtClean="0"/>
               <a:t>Third level</a:t>
             </a:r>
+            <a:endParaRPr lang="en-US" smtClean="0"/>
           </a:p>
           <a:p>
             <a:pPr lvl="3"/>
@@ -2685,6 +2664,7 @@
               <a:rPr lang="en-US" smtClean="0"/>
               <a:t>Fourth level</a:t>
             </a:r>
+            <a:endParaRPr lang="en-US" smtClean="0"/>
           </a:p>
           <a:p>
             <a:pPr lvl="4"/>
@@ -2731,7 +2711,6 @@
           <a:p>
             <a:fld id="{5BCAD085-E8A6-8845-BD4E-CB4CCA059FC4}" type="datetimeFigureOut">
               <a:rPr lang="en-US" smtClean="0"/>
-              <a:t>1/27/13</a:t>
             </a:fld>
             <a:endParaRPr lang="en-US"/>
           </a:p>
@@ -2809,18 +2788,12 @@
           <a:p>
             <a:fld id="{C1FF6DA9-008F-8B48-92A6-B652298478BF}" type="slidenum">
               <a:rPr lang="en-US" smtClean="0"/>
-              <a:t>‹#›</a:t>
             </a:fld>
             <a:endParaRPr lang="en-US"/>
           </a:p>
         </p:txBody>
       </p:sp>
     </p:spTree>
-    <p:extLst>
-      <p:ext uri="{BB962C8B-B14F-4D97-AF65-F5344CB8AC3E}">
-        <p14:creationId xmlns:p14="http://schemas.microsoft.com/office/powerpoint/2010/main" val="2209977519"/>
-      </p:ext>
-    </p:extLst>
   </p:cSld>
   <p:clrMap bg1="lt1" tx1="dk1" bg2="lt2" tx2="dk2" accent1="accent1" accent2="accent2" accent3="accent3" accent4="accent4" accent5="accent5" accent6="accent6" hlink="hlink" folHlink="folHlink"/>
   <p:sldLayoutIdLst>
@@ -2858,7 +2831,7 @@
         <a:spcBef>
           <a:spcPct val="20000"/>
         </a:spcBef>
-        <a:buFont typeface="Arial"/>
+        <a:buFont typeface="Arial" panose="020B0604020202020204"/>
         <a:buChar char="•"/>
         <a:defRPr sz="3200" kern="1200">
           <a:solidFill>
@@ -2873,7 +2846,7 @@
         <a:spcBef>
           <a:spcPct val="20000"/>
         </a:spcBef>
-        <a:buFont typeface="Arial"/>
+        <a:buFont typeface="Arial" panose="020B0604020202020204"/>
         <a:buChar char="–"/>
         <a:defRPr sz="2800" kern="1200">
           <a:solidFill>
@@ -2888,7 +2861,7 @@
         <a:spcBef>
           <a:spcPct val="20000"/>
         </a:spcBef>
-        <a:buFont typeface="Arial"/>
+        <a:buFont typeface="Arial" panose="020B0604020202020204"/>
         <a:buChar char="•"/>
         <a:defRPr sz="2400" kern="1200">
           <a:solidFill>
@@ -2903,7 +2876,7 @@
         <a:spcBef>
           <a:spcPct val="20000"/>
         </a:spcBef>
-        <a:buFont typeface="Arial"/>
+        <a:buFont typeface="Arial" panose="020B0604020202020204"/>
         <a:buChar char="–"/>
         <a:defRPr sz="2000" kern="1200">
           <a:solidFill>
@@ -2918,7 +2891,7 @@
         <a:spcBef>
           <a:spcPct val="20000"/>
         </a:spcBef>
-        <a:buFont typeface="Arial"/>
+        <a:buFont typeface="Arial" panose="020B0604020202020204"/>
         <a:buChar char="»"/>
         <a:defRPr sz="2000" kern="1200">
           <a:solidFill>
@@ -2933,7 +2906,7 @@
         <a:spcBef>
           <a:spcPct val="20000"/>
         </a:spcBef>
-        <a:buFont typeface="Arial"/>
+        <a:buFont typeface="Arial" panose="020B0604020202020204"/>
         <a:buChar char="•"/>
         <a:defRPr sz="2000" kern="1200">
           <a:solidFill>
@@ -2948,7 +2921,7 @@
         <a:spcBef>
           <a:spcPct val="20000"/>
         </a:spcBef>
-        <a:buFont typeface="Arial"/>
+        <a:buFont typeface="Arial" panose="020B0604020202020204"/>
         <a:buChar char="•"/>
         <a:defRPr sz="2000" kern="1200">
           <a:solidFill>
@@ -2963,7 +2936,7 @@
         <a:spcBef>
           <a:spcPct val="20000"/>
         </a:spcBef>
-        <a:buFont typeface="Arial"/>
+        <a:buFont typeface="Arial" panose="020B0604020202020204"/>
         <a:buChar char="•"/>
         <a:defRPr sz="2000" kern="1200">
           <a:solidFill>
@@ -2978,7 +2951,7 @@
         <a:spcBef>
           <a:spcPct val="20000"/>
         </a:spcBef>
-        <a:buFont typeface="Arial"/>
+        <a:buFont typeface="Arial" panose="020B0604020202020204"/>
         <a:buChar char="•"/>
         <a:defRPr sz="2000" kern="1200">
           <a:solidFill>
@@ -3090,7 +3063,7 @@
 </file>
 
 <file path=ppt/slides/slide1.xml><?xml version="1.0" encoding="utf-8"?>
-<p:sld xmlns:a="http://schemas.openxmlformats.org/drawingml/2006/main" xmlns:p="http://schemas.openxmlformats.org/presentationml/2006/main" xmlns:r="http://schemas.openxmlformats.org/officeDocument/2006/relationships">
+<p:sld xmlns:a="http://schemas.openxmlformats.org/drawingml/2006/main" xmlns:r="http://schemas.openxmlformats.org/officeDocument/2006/relationships" xmlns:p="http://schemas.openxmlformats.org/presentationml/2006/main">
   <p:cSld>
     <p:bg>
       <p:bgPr>
@@ -3180,7 +3153,7 @@
                 <a:solidFill>
                   <a:srgbClr val="FFFFFF"/>
                 </a:solidFill>
-                <a:latin typeface="Arial"/>
+                <a:latin typeface="Arial" panose="020B0604020202020204"/>
               </a:defRPr>
             </a:pPr>
             <a:r>
@@ -3193,7 +3166,7 @@
                 <a:solidFill>
                   <a:srgbClr val="818CF8"/>
                 </a:solidFill>
-                <a:latin typeface="Arial"/>
+                <a:latin typeface="Arial" panose="020B0604020202020204"/>
               </a:defRPr>
             </a:pPr>
             <a:r>
@@ -3229,7 +3202,7 @@
                 <a:solidFill>
                   <a:srgbClr val="94A3B8"/>
                 </a:solidFill>
-                <a:latin typeface="Arial"/>
+                <a:latin typeface="Arial" panose="020B0604020202020204"/>
               </a:defRPr>
             </a:pPr>
             <a:r>
@@ -3251,7 +3224,7 @@
 </file>
 
 <file path=ppt/slides/slide10.xml><?xml version="1.0" encoding="utf-8"?>
-<p:sld xmlns:a="http://schemas.openxmlformats.org/drawingml/2006/main" xmlns:p="http://schemas.openxmlformats.org/presentationml/2006/main" xmlns:r="http://schemas.openxmlformats.org/officeDocument/2006/relationships">
+<p:sld xmlns:a="http://schemas.openxmlformats.org/drawingml/2006/main" xmlns:r="http://schemas.openxmlformats.org/officeDocument/2006/relationships" xmlns:p="http://schemas.openxmlformats.org/presentationml/2006/main">
   <p:cSld>
     <p:bg>
       <p:bgPr>
@@ -3295,7 +3268,7 @@
                 <a:solidFill>
                   <a:srgbClr val="818CF8"/>
                 </a:solidFill>
-                <a:latin typeface="Arial"/>
+                <a:latin typeface="Arial" panose="020B0604020202020204"/>
               </a:defRPr>
             </a:pPr>
             <a:r>
@@ -3334,7 +3307,7 @@
                 <a:solidFill>
                   <a:srgbClr val="FFFFFF"/>
                 </a:solidFill>
-                <a:latin typeface="Arial"/>
+                <a:latin typeface="Arial" panose="020B0604020202020204"/>
               </a:defRPr>
             </a:pPr>
             <a:r>
@@ -3350,7 +3323,7 @@
                 <a:solidFill>
                   <a:srgbClr val="FFFFFF"/>
                 </a:solidFill>
-                <a:latin typeface="Arial"/>
+                <a:latin typeface="Arial" panose="020B0604020202020204"/>
               </a:defRPr>
             </a:pPr>
             <a:r>
@@ -3366,7 +3339,7 @@
                 <a:solidFill>
                   <a:srgbClr val="FFFFFF"/>
                 </a:solidFill>
-                <a:latin typeface="Arial"/>
+                <a:latin typeface="Arial" panose="020B0604020202020204"/>
               </a:defRPr>
             </a:pPr>
             <a:r>
@@ -3382,7 +3355,7 @@
                 <a:solidFill>
                   <a:srgbClr val="FFFFFF"/>
                 </a:solidFill>
-                <a:latin typeface="Arial"/>
+                <a:latin typeface="Arial" panose="020B0604020202020204"/>
               </a:defRPr>
             </a:pPr>
             <a:r>
@@ -3398,7 +3371,7 @@
                 <a:solidFill>
                   <a:srgbClr val="FFFFFF"/>
                 </a:solidFill>
-                <a:latin typeface="Arial"/>
+                <a:latin typeface="Arial" panose="020B0604020202020204"/>
               </a:defRPr>
             </a:pPr>
             <a:r>
@@ -3414,7 +3387,7 @@
                 <a:solidFill>
                   <a:srgbClr val="FFFFFF"/>
                 </a:solidFill>
-                <a:latin typeface="Arial"/>
+                <a:latin typeface="Arial" panose="020B0604020202020204"/>
               </a:defRPr>
             </a:pPr>
             <a:r>
@@ -3430,7 +3403,7 @@
                 <a:solidFill>
                   <a:srgbClr val="FFFFFF"/>
                 </a:solidFill>
-                <a:latin typeface="Arial"/>
+                <a:latin typeface="Arial" panose="020B0604020202020204"/>
               </a:defRPr>
             </a:pPr>
             <a:r>
@@ -3446,7 +3419,7 @@
                 <a:solidFill>
                   <a:srgbClr val="FFFFFF"/>
                 </a:solidFill>
-                <a:latin typeface="Arial"/>
+                <a:latin typeface="Arial" panose="020B0604020202020204"/>
               </a:defRPr>
             </a:pPr>
             <a:r>
@@ -3464,7 +3437,7 @@
 </file>
 
 <file path=ppt/slides/slide11.xml><?xml version="1.0" encoding="utf-8"?>
-<p:sld xmlns:a="http://schemas.openxmlformats.org/drawingml/2006/main" xmlns:p="http://schemas.openxmlformats.org/presentationml/2006/main" xmlns:r="http://schemas.openxmlformats.org/officeDocument/2006/relationships">
+<p:sld xmlns:a="http://schemas.openxmlformats.org/drawingml/2006/main" xmlns:r="http://schemas.openxmlformats.org/officeDocument/2006/relationships" xmlns:p="http://schemas.openxmlformats.org/presentationml/2006/main">
   <p:cSld>
     <p:bg>
       <p:bgPr>
@@ -3508,7 +3481,7 @@
                 <a:solidFill>
                   <a:srgbClr val="818CF8"/>
                 </a:solidFill>
-                <a:latin typeface="Arial"/>
+                <a:latin typeface="Arial" panose="020B0604020202020204"/>
               </a:defRPr>
             </a:pPr>
             <a:r>
@@ -3547,7 +3520,7 @@
                 <a:solidFill>
                   <a:srgbClr val="FFFFFF"/>
                 </a:solidFill>
-                <a:latin typeface="Arial"/>
+                <a:latin typeface="Arial" panose="020B0604020202020204"/>
               </a:defRPr>
             </a:pPr>
             <a:r>
@@ -3563,7 +3536,7 @@
                 <a:solidFill>
                   <a:srgbClr val="FFFFFF"/>
                 </a:solidFill>
-                <a:latin typeface="Arial"/>
+                <a:latin typeface="Arial" panose="020B0604020202020204"/>
               </a:defRPr>
             </a:pPr>
             <a:r>
@@ -3579,7 +3552,7 @@
                 <a:solidFill>
                   <a:srgbClr val="FFFFFF"/>
                 </a:solidFill>
-                <a:latin typeface="Arial"/>
+                <a:latin typeface="Arial" panose="020B0604020202020204"/>
               </a:defRPr>
             </a:pPr>
             <a:r>
@@ -3595,7 +3568,7 @@
                 <a:solidFill>
                   <a:srgbClr val="FFFFFF"/>
                 </a:solidFill>
-                <a:latin typeface="Arial"/>
+                <a:latin typeface="Arial" panose="020B0604020202020204"/>
               </a:defRPr>
             </a:pPr>
             <a:r>
@@ -3611,7 +3584,7 @@
                 <a:solidFill>
                   <a:srgbClr val="FFFFFF"/>
                 </a:solidFill>
-                <a:latin typeface="Arial"/>
+                <a:latin typeface="Arial" panose="020B0604020202020204"/>
               </a:defRPr>
             </a:pPr>
             <a:r>
@@ -3627,7 +3600,7 @@
                 <a:solidFill>
                   <a:srgbClr val="FFFFFF"/>
                 </a:solidFill>
-                <a:latin typeface="Arial"/>
+                <a:latin typeface="Arial" panose="020B0604020202020204"/>
               </a:defRPr>
             </a:pPr>
             <a:r>
@@ -3643,7 +3616,7 @@
                 <a:solidFill>
                   <a:srgbClr val="FFFFFF"/>
                 </a:solidFill>
-                <a:latin typeface="Arial"/>
+                <a:latin typeface="Arial" panose="020B0604020202020204"/>
               </a:defRPr>
             </a:pPr>
             <a:r>
@@ -3659,7 +3632,7 @@
                 <a:solidFill>
                   <a:srgbClr val="FFFFFF"/>
                 </a:solidFill>
-                <a:latin typeface="Arial"/>
+                <a:latin typeface="Arial" panose="020B0604020202020204"/>
               </a:defRPr>
             </a:pPr>
             <a:r>
@@ -3675,7 +3648,7 @@
                 <a:solidFill>
                   <a:srgbClr val="FFFFFF"/>
                 </a:solidFill>
-                <a:latin typeface="Arial"/>
+                <a:latin typeface="Arial" panose="020B0604020202020204"/>
               </a:defRPr>
             </a:pPr>
             <a:r>
@@ -3691,7 +3664,7 @@
                 <a:solidFill>
                   <a:srgbClr val="FFFFFF"/>
                 </a:solidFill>
-                <a:latin typeface="Arial"/>
+                <a:latin typeface="Arial" panose="020B0604020202020204"/>
               </a:defRPr>
             </a:pPr>
             <a:r>
@@ -3709,7 +3682,7 @@
 </file>
 
 <file path=ppt/slides/slide12.xml><?xml version="1.0" encoding="utf-8"?>
-<p:sld xmlns:a="http://schemas.openxmlformats.org/drawingml/2006/main" xmlns:p="http://schemas.openxmlformats.org/presentationml/2006/main" xmlns:r="http://schemas.openxmlformats.org/officeDocument/2006/relationships">
+<p:sld xmlns:a="http://schemas.openxmlformats.org/drawingml/2006/main" xmlns:r="http://schemas.openxmlformats.org/officeDocument/2006/relationships" xmlns:p="http://schemas.openxmlformats.org/presentationml/2006/main">
   <p:cSld>
     <p:bg>
       <p:bgPr>
@@ -3753,7 +3726,7 @@
                 <a:solidFill>
                   <a:srgbClr val="818CF8"/>
                 </a:solidFill>
-                <a:latin typeface="Arial"/>
+                <a:latin typeface="Arial" panose="020B0604020202020204"/>
               </a:defRPr>
             </a:pPr>
             <a:r>
@@ -3769,7 +3742,7 @@
                 <a:solidFill>
                   <a:srgbClr val="FFFFFF"/>
                 </a:solidFill>
-                <a:latin typeface="Arial"/>
+                <a:latin typeface="Arial" panose="020B0604020202020204"/>
               </a:defRPr>
             </a:pPr>
             <a:r>
@@ -3805,7 +3778,7 @@
                 <a:solidFill>
                   <a:srgbClr val="94A3B8"/>
                 </a:solidFill>
-                <a:latin typeface="Arial"/>
+                <a:latin typeface="Arial" panose="020B0604020202020204"/>
               </a:defRPr>
             </a:pPr>
             <a:r>
@@ -3827,7 +3800,7 @@
 </file>
 
 <file path=ppt/slides/slide2.xml><?xml version="1.0" encoding="utf-8"?>
-<p:sld xmlns:a="http://schemas.openxmlformats.org/drawingml/2006/main" xmlns:p="http://schemas.openxmlformats.org/presentationml/2006/main" xmlns:r="http://schemas.openxmlformats.org/officeDocument/2006/relationships">
+<p:sld xmlns:a="http://schemas.openxmlformats.org/drawingml/2006/main" xmlns:r="http://schemas.openxmlformats.org/officeDocument/2006/relationships" xmlns:p="http://schemas.openxmlformats.org/presentationml/2006/main">
   <p:cSld>
     <p:bg>
       <p:bgPr>
@@ -3871,7 +3844,7 @@
                 <a:solidFill>
                   <a:srgbClr val="818CF8"/>
                 </a:solidFill>
-                <a:latin typeface="Arial"/>
+                <a:latin typeface="Arial" panose="020B0604020202020204"/>
               </a:defRPr>
             </a:pPr>
             <a:r>
@@ -3910,7 +3883,7 @@
                 <a:solidFill>
                   <a:srgbClr val="FFFFFF"/>
                 </a:solidFill>
-                <a:latin typeface="Arial"/>
+                <a:latin typeface="Arial" panose="020B0604020202020204"/>
               </a:defRPr>
             </a:pPr>
             <a:r>
@@ -3926,7 +3899,7 @@
                 <a:solidFill>
                   <a:srgbClr val="FFFFFF"/>
                 </a:solidFill>
-                <a:latin typeface="Arial"/>
+                <a:latin typeface="Arial" panose="020B0604020202020204"/>
               </a:defRPr>
             </a:pPr>
             <a:r>
@@ -3942,7 +3915,7 @@
                 <a:solidFill>
                   <a:srgbClr val="FFFFFF"/>
                 </a:solidFill>
-                <a:latin typeface="Arial"/>
+                <a:latin typeface="Arial" panose="020B0604020202020204"/>
               </a:defRPr>
             </a:pPr>
             <a:r>
@@ -3958,7 +3931,7 @@
                 <a:solidFill>
                   <a:srgbClr val="FFFFFF"/>
                 </a:solidFill>
-                <a:latin typeface="Arial"/>
+                <a:latin typeface="Arial" panose="020B0604020202020204"/>
               </a:defRPr>
             </a:pPr>
             <a:r>
@@ -3974,7 +3947,7 @@
                 <a:solidFill>
                   <a:srgbClr val="FFFFFF"/>
                 </a:solidFill>
-                <a:latin typeface="Arial"/>
+                <a:latin typeface="Arial" panose="020B0604020202020204"/>
               </a:defRPr>
             </a:pPr>
             <a:r>
@@ -3990,7 +3963,7 @@
                 <a:solidFill>
                   <a:srgbClr val="FFFFFF"/>
                 </a:solidFill>
-                <a:latin typeface="Arial"/>
+                <a:latin typeface="Arial" panose="020B0604020202020204"/>
               </a:defRPr>
             </a:pPr>
             <a:r>
@@ -4006,7 +3979,7 @@
                 <a:solidFill>
                   <a:srgbClr val="FFFFFF"/>
                 </a:solidFill>
-                <a:latin typeface="Arial"/>
+                <a:latin typeface="Arial" panose="020B0604020202020204"/>
               </a:defRPr>
             </a:pPr>
             <a:r>
@@ -4024,7 +3997,7 @@
 </file>
 
 <file path=ppt/slides/slide3.xml><?xml version="1.0" encoding="utf-8"?>
-<p:sld xmlns:a="http://schemas.openxmlformats.org/drawingml/2006/main" xmlns:p="http://schemas.openxmlformats.org/presentationml/2006/main" xmlns:r="http://schemas.openxmlformats.org/officeDocument/2006/relationships">
+<p:sld xmlns:a="http://schemas.openxmlformats.org/drawingml/2006/main" xmlns:r="http://schemas.openxmlformats.org/officeDocument/2006/relationships" xmlns:p="http://schemas.openxmlformats.org/presentationml/2006/main">
   <p:cSld>
     <p:bg>
       <p:bgPr>
@@ -4068,7 +4041,7 @@
                 <a:solidFill>
                   <a:srgbClr val="818CF8"/>
                 </a:solidFill>
-                <a:latin typeface="Arial"/>
+                <a:latin typeface="Arial" panose="020B0604020202020204"/>
               </a:defRPr>
             </a:pPr>
             <a:r>
@@ -4107,7 +4080,7 @@
                 <a:solidFill>
                   <a:srgbClr val="FFFFFF"/>
                 </a:solidFill>
-                <a:latin typeface="Arial"/>
+                <a:latin typeface="Arial" panose="020B0604020202020204"/>
               </a:defRPr>
             </a:pPr>
             <a:r>
@@ -4123,7 +4096,7 @@
                 <a:solidFill>
                   <a:srgbClr val="FFFFFF"/>
                 </a:solidFill>
-                <a:latin typeface="Arial"/>
+                <a:latin typeface="Arial" panose="020B0604020202020204"/>
               </a:defRPr>
             </a:pPr>
             <a:r>
@@ -4139,7 +4112,7 @@
                 <a:solidFill>
                   <a:srgbClr val="FFFFFF"/>
                 </a:solidFill>
-                <a:latin typeface="Arial"/>
+                <a:latin typeface="Arial" panose="020B0604020202020204"/>
               </a:defRPr>
             </a:pPr>
             <a:r>
@@ -4155,7 +4128,7 @@
                 <a:solidFill>
                   <a:srgbClr val="FFFFFF"/>
                 </a:solidFill>
-                <a:latin typeface="Arial"/>
+                <a:latin typeface="Arial" panose="020B0604020202020204"/>
               </a:defRPr>
             </a:pPr>
             <a:r>
@@ -4171,7 +4144,7 @@
                 <a:solidFill>
                   <a:srgbClr val="FFFFFF"/>
                 </a:solidFill>
-                <a:latin typeface="Arial"/>
+                <a:latin typeface="Arial" panose="020B0604020202020204"/>
               </a:defRPr>
             </a:pPr>
             <a:r>
@@ -4187,7 +4160,7 @@
                 <a:solidFill>
                   <a:srgbClr val="FFFFFF"/>
                 </a:solidFill>
-                <a:latin typeface="Arial"/>
+                <a:latin typeface="Arial" panose="020B0604020202020204"/>
               </a:defRPr>
             </a:pPr>
             <a:r>
@@ -4203,7 +4176,7 @@
                 <a:solidFill>
                   <a:srgbClr val="FFFFFF"/>
                 </a:solidFill>
-                <a:latin typeface="Arial"/>
+                <a:latin typeface="Arial" panose="020B0604020202020204"/>
               </a:defRPr>
             </a:pPr>
             <a:r>
@@ -4219,7 +4192,7 @@
                 <a:solidFill>
                   <a:srgbClr val="FFFFFF"/>
                 </a:solidFill>
-                <a:latin typeface="Arial"/>
+                <a:latin typeface="Arial" panose="020B0604020202020204"/>
               </a:defRPr>
             </a:pPr>
             <a:r>
@@ -4237,7 +4210,7 @@
 </file>
 
 <file path=ppt/slides/slide4.xml><?xml version="1.0" encoding="utf-8"?>
-<p:sld xmlns:a="http://schemas.openxmlformats.org/drawingml/2006/main" xmlns:p="http://schemas.openxmlformats.org/presentationml/2006/main" xmlns:r="http://schemas.openxmlformats.org/officeDocument/2006/relationships">
+<p:sld xmlns:a="http://schemas.openxmlformats.org/drawingml/2006/main" xmlns:r="http://schemas.openxmlformats.org/officeDocument/2006/relationships" xmlns:p="http://schemas.openxmlformats.org/presentationml/2006/main">
   <p:cSld>
     <p:bg>
       <p:bgPr>
@@ -4281,7 +4254,7 @@
                 <a:solidFill>
                   <a:srgbClr val="818CF8"/>
                 </a:solidFill>
-                <a:latin typeface="Arial"/>
+                <a:latin typeface="Arial" panose="020B0604020202020204"/>
               </a:defRPr>
             </a:pPr>
             <a:r>
@@ -4320,7 +4293,7 @@
                 <a:solidFill>
                   <a:srgbClr val="FFFFFF"/>
                 </a:solidFill>
-                <a:latin typeface="Arial"/>
+                <a:latin typeface="Arial" panose="020B0604020202020204"/>
               </a:defRPr>
             </a:pPr>
             <a:r>
@@ -4336,7 +4309,7 @@
                 <a:solidFill>
                   <a:srgbClr val="FFFFFF"/>
                 </a:solidFill>
-                <a:latin typeface="Arial"/>
+                <a:latin typeface="Arial" panose="020B0604020202020204"/>
               </a:defRPr>
             </a:pPr>
             <a:r>
@@ -4352,7 +4325,7 @@
                 <a:solidFill>
                   <a:srgbClr val="FFFFFF"/>
                 </a:solidFill>
-                <a:latin typeface="Arial"/>
+                <a:latin typeface="Arial" panose="020B0604020202020204"/>
               </a:defRPr>
             </a:pPr>
             <a:r>
@@ -4368,7 +4341,7 @@
                 <a:solidFill>
                   <a:srgbClr val="FFFFFF"/>
                 </a:solidFill>
-                <a:latin typeface="Arial"/>
+                <a:latin typeface="Arial" panose="020B0604020202020204"/>
               </a:defRPr>
             </a:pPr>
             <a:r>
@@ -4384,7 +4357,7 @@
                 <a:solidFill>
                   <a:srgbClr val="FFFFFF"/>
                 </a:solidFill>
-                <a:latin typeface="Arial"/>
+                <a:latin typeface="Arial" panose="020B0604020202020204"/>
               </a:defRPr>
             </a:pPr>
             <a:r>
@@ -4400,7 +4373,7 @@
                 <a:solidFill>
                   <a:srgbClr val="FFFFFF"/>
                 </a:solidFill>
-                <a:latin typeface="Arial"/>
+                <a:latin typeface="Arial" panose="020B0604020202020204"/>
               </a:defRPr>
             </a:pPr>
             <a:r>
@@ -4416,7 +4389,7 @@
                 <a:solidFill>
                   <a:srgbClr val="FFFFFF"/>
                 </a:solidFill>
-                <a:latin typeface="Arial"/>
+                <a:latin typeface="Arial" panose="020B0604020202020204"/>
               </a:defRPr>
             </a:pPr>
             <a:r>
@@ -4432,7 +4405,7 @@
                 <a:solidFill>
                   <a:srgbClr val="FFFFFF"/>
                 </a:solidFill>
-                <a:latin typeface="Arial"/>
+                <a:latin typeface="Arial" panose="020B0604020202020204"/>
               </a:defRPr>
             </a:pPr>
             <a:r>
@@ -4450,7 +4423,7 @@
 </file>
 
 <file path=ppt/slides/slide5.xml><?xml version="1.0" encoding="utf-8"?>
-<p:sld xmlns:a="http://schemas.openxmlformats.org/drawingml/2006/main" xmlns:p="http://schemas.openxmlformats.org/presentationml/2006/main" xmlns:r="http://schemas.openxmlformats.org/officeDocument/2006/relationships">
+<p:sld xmlns:a="http://schemas.openxmlformats.org/drawingml/2006/main" xmlns:r="http://schemas.openxmlformats.org/officeDocument/2006/relationships" xmlns:p="http://schemas.openxmlformats.org/presentationml/2006/main">
   <p:cSld>
     <p:bg>
       <p:bgPr>
@@ -4494,7 +4467,7 @@
                 <a:solidFill>
                   <a:srgbClr val="818CF8"/>
                 </a:solidFill>
-                <a:latin typeface="Arial"/>
+                <a:latin typeface="Arial" panose="020B0604020202020204"/>
               </a:defRPr>
             </a:pPr>
             <a:r>
@@ -4533,7 +4506,7 @@
                 <a:solidFill>
                   <a:srgbClr val="FFFFFF"/>
                 </a:solidFill>
-                <a:latin typeface="Arial"/>
+                <a:latin typeface="Arial" panose="020B0604020202020204"/>
               </a:defRPr>
             </a:pPr>
             <a:r>
@@ -4549,7 +4522,7 @@
                 <a:solidFill>
                   <a:srgbClr val="FFFFFF"/>
                 </a:solidFill>
-                <a:latin typeface="Arial"/>
+                <a:latin typeface="Arial" panose="020B0604020202020204"/>
               </a:defRPr>
             </a:pPr>
             <a:r>
@@ -4565,7 +4538,7 @@
                 <a:solidFill>
                   <a:srgbClr val="FFFFFF"/>
                 </a:solidFill>
-                <a:latin typeface="Arial"/>
+                <a:latin typeface="Arial" panose="020B0604020202020204"/>
               </a:defRPr>
             </a:pPr>
             <a:r>
@@ -4581,7 +4554,7 @@
                 <a:solidFill>
                   <a:srgbClr val="FFFFFF"/>
                 </a:solidFill>
-                <a:latin typeface="Arial"/>
+                <a:latin typeface="Arial" panose="020B0604020202020204"/>
               </a:defRPr>
             </a:pPr>
             <a:r>
@@ -4597,7 +4570,7 @@
                 <a:solidFill>
                   <a:srgbClr val="FFFFFF"/>
                 </a:solidFill>
-                <a:latin typeface="Arial"/>
+                <a:latin typeface="Arial" panose="020B0604020202020204"/>
               </a:defRPr>
             </a:pPr>
             <a:r>
@@ -4613,7 +4586,7 @@
                 <a:solidFill>
                   <a:srgbClr val="FFFFFF"/>
                 </a:solidFill>
-                <a:latin typeface="Arial"/>
+                <a:latin typeface="Arial" panose="020B0604020202020204"/>
               </a:defRPr>
             </a:pPr>
             <a:r>
@@ -4629,7 +4602,7 @@
                 <a:solidFill>
                   <a:srgbClr val="FFFFFF"/>
                 </a:solidFill>
-                <a:latin typeface="Arial"/>
+                <a:latin typeface="Arial" panose="020B0604020202020204"/>
               </a:defRPr>
             </a:pPr>
             <a:r>
@@ -4645,7 +4618,7 @@
                 <a:solidFill>
                   <a:srgbClr val="FFFFFF"/>
                 </a:solidFill>
-                <a:latin typeface="Arial"/>
+                <a:latin typeface="Arial" panose="020B0604020202020204"/>
               </a:defRPr>
             </a:pPr>
             <a:r>
@@ -4663,7 +4636,7 @@
 </file>
 
 <file path=ppt/slides/slide6.xml><?xml version="1.0" encoding="utf-8"?>
-<p:sld xmlns:a="http://schemas.openxmlformats.org/drawingml/2006/main" xmlns:p="http://schemas.openxmlformats.org/presentationml/2006/main" xmlns:r="http://schemas.openxmlformats.org/officeDocument/2006/relationships">
+<p:sld xmlns:a="http://schemas.openxmlformats.org/drawingml/2006/main" xmlns:r="http://schemas.openxmlformats.org/officeDocument/2006/relationships" xmlns:p="http://schemas.openxmlformats.org/presentationml/2006/main">
   <p:cSld>
     <p:bg>
       <p:bgPr>
@@ -4707,7 +4680,7 @@
                 <a:solidFill>
                   <a:srgbClr val="818CF8"/>
                 </a:solidFill>
-                <a:latin typeface="Arial"/>
+                <a:latin typeface="Arial" panose="020B0604020202020204"/>
               </a:defRPr>
             </a:pPr>
             <a:r>
@@ -4725,7 +4698,7 @@
         <p:spPr>
           <a:xfrm>
             <a:off x="457200" y="1188720"/>
-            <a:ext cx="8229600" cy="3474720"/>
+            <a:ext cx="8229600" cy="2886710"/>
           </a:xfrm>
           <a:prstGeom prst="rect">
             <a:avLst/>
@@ -4738,15 +4711,17 @@
           </a:bodyPr>
           <a:lstStyle/>
           <a:p>
-            <a:pPr>
-              <a:spcAft>
-                <a:spcPts val="800"/>
-              </a:spcAft>
-              <a:defRPr sz="1500">
-                <a:solidFill>
-                  <a:srgbClr val="FFFFFF"/>
-                </a:solidFill>
-                <a:latin typeface="Arial"/>
+            <a:pPr marL="285750" indent="-285750">
+              <a:spcAft>
+                <a:spcPts val="800"/>
+              </a:spcAft>
+              <a:buFont typeface="Arial" panose="020B0604020202020204" pitchFamily="34" charset="0"/>
+              <a:buChar char="•"/>
+              <a:defRPr sz="1500">
+                <a:solidFill>
+                  <a:srgbClr val="FFFFFF"/>
+                </a:solidFill>
+                <a:latin typeface="Arial" panose="020B0604020202020204"/>
               </a:defRPr>
             </a:pPr>
             <a:r>
@@ -4754,15 +4729,17 @@
             </a:r>
           </a:p>
           <a:p>
-            <a:pPr>
-              <a:spcAft>
-                <a:spcPts val="800"/>
-              </a:spcAft>
-              <a:defRPr sz="1500">
-                <a:solidFill>
-                  <a:srgbClr val="FFFFFF"/>
-                </a:solidFill>
-                <a:latin typeface="Arial"/>
+            <a:pPr indent="0">
+              <a:spcAft>
+                <a:spcPts val="800"/>
+              </a:spcAft>
+              <a:buFont typeface="Arial" panose="020B0604020202020204" pitchFamily="34" charset="0"/>
+              <a:buNone/>
+              <a:defRPr sz="1500">
+                <a:solidFill>
+                  <a:srgbClr val="FFFFFF"/>
+                </a:solidFill>
+                <a:latin typeface="Arial" panose="020B0604020202020204"/>
               </a:defRPr>
             </a:pPr>
             <a:r>
@@ -4770,15 +4747,17 @@
             </a:r>
           </a:p>
           <a:p>
-            <a:pPr>
-              <a:spcAft>
-                <a:spcPts val="800"/>
-              </a:spcAft>
-              <a:defRPr sz="1500">
-                <a:solidFill>
-                  <a:srgbClr val="FFFFFF"/>
-                </a:solidFill>
-                <a:latin typeface="Arial"/>
+            <a:pPr marL="285750" indent="-285750">
+              <a:spcAft>
+                <a:spcPts val="800"/>
+              </a:spcAft>
+              <a:buFont typeface="Arial" panose="020B0604020202020204" pitchFamily="34" charset="0"/>
+              <a:buChar char="•"/>
+              <a:defRPr sz="1500">
+                <a:solidFill>
+                  <a:srgbClr val="FFFFFF"/>
+                </a:solidFill>
+                <a:latin typeface="Arial" panose="020B0604020202020204"/>
               </a:defRPr>
             </a:pPr>
             <a:r>
@@ -4786,15 +4765,17 @@
             </a:r>
           </a:p>
           <a:p>
-            <a:pPr>
-              <a:spcAft>
-                <a:spcPts val="800"/>
-              </a:spcAft>
-              <a:defRPr sz="1500">
-                <a:solidFill>
-                  <a:srgbClr val="FFFFFF"/>
-                </a:solidFill>
-                <a:latin typeface="Arial"/>
+            <a:pPr indent="0">
+              <a:spcAft>
+                <a:spcPts val="800"/>
+              </a:spcAft>
+              <a:buFont typeface="Arial" panose="020B0604020202020204" pitchFamily="34" charset="0"/>
+              <a:buNone/>
+              <a:defRPr sz="1500">
+                <a:solidFill>
+                  <a:srgbClr val="FFFFFF"/>
+                </a:solidFill>
+                <a:latin typeface="Arial" panose="020B0604020202020204"/>
               </a:defRPr>
             </a:pPr>
             <a:r>
@@ -4802,15 +4783,17 @@
             </a:r>
           </a:p>
           <a:p>
-            <a:pPr>
-              <a:spcAft>
-                <a:spcPts val="800"/>
-              </a:spcAft>
-              <a:defRPr sz="1500">
-                <a:solidFill>
-                  <a:srgbClr val="FFFFFF"/>
-                </a:solidFill>
-                <a:latin typeface="Arial"/>
+            <a:pPr marL="285750" indent="-285750">
+              <a:spcAft>
+                <a:spcPts val="800"/>
+              </a:spcAft>
+              <a:buFont typeface="Arial" panose="020B0604020202020204" pitchFamily="34" charset="0"/>
+              <a:buChar char="•"/>
+              <a:defRPr sz="1500">
+                <a:solidFill>
+                  <a:srgbClr val="FFFFFF"/>
+                </a:solidFill>
+                <a:latin typeface="Arial" panose="020B0604020202020204"/>
               </a:defRPr>
             </a:pPr>
             <a:r>
@@ -4818,15 +4801,17 @@
             </a:r>
           </a:p>
           <a:p>
-            <a:pPr>
-              <a:spcAft>
-                <a:spcPts val="800"/>
-              </a:spcAft>
-              <a:defRPr sz="1500">
-                <a:solidFill>
-                  <a:srgbClr val="FFFFFF"/>
-                </a:solidFill>
-                <a:latin typeface="Arial"/>
+            <a:pPr marL="285750" indent="-285750">
+              <a:spcAft>
+                <a:spcPts val="800"/>
+              </a:spcAft>
+              <a:buFont typeface="Arial" panose="020B0604020202020204" pitchFamily="34" charset="0"/>
+              <a:buChar char="•"/>
+              <a:defRPr sz="1500">
+                <a:solidFill>
+                  <a:srgbClr val="FFFFFF"/>
+                </a:solidFill>
+                <a:latin typeface="Arial" panose="020B0604020202020204"/>
               </a:defRPr>
             </a:pPr>
             <a:r>
@@ -4834,15 +4819,17 @@
             </a:r>
           </a:p>
           <a:p>
-            <a:pPr lvl="1">
-              <a:spcAft>
-                <a:spcPts val="800"/>
-              </a:spcAft>
-              <a:defRPr sz="1500">
-                <a:solidFill>
-                  <a:srgbClr val="FFFFFF"/>
-                </a:solidFill>
-                <a:latin typeface="Arial"/>
+            <a:pPr marL="742950" lvl="1" indent="-285750">
+              <a:spcAft>
+                <a:spcPts val="800"/>
+              </a:spcAft>
+              <a:buFont typeface="Arial" panose="020B0604020202020204" pitchFamily="34" charset="0"/>
+              <a:buChar char="•"/>
+              <a:defRPr sz="1500">
+                <a:solidFill>
+                  <a:srgbClr val="FFFFFF"/>
+                </a:solidFill>
+                <a:latin typeface="Arial" panose="020B0604020202020204"/>
               </a:defRPr>
             </a:pPr>
             <a:r>
@@ -4850,35 +4837,21 @@
             </a:r>
           </a:p>
           <a:p>
-            <a:pPr lvl="1">
-              <a:spcAft>
-                <a:spcPts val="800"/>
-              </a:spcAft>
-              <a:defRPr sz="1500">
-                <a:solidFill>
-                  <a:srgbClr val="FFFFFF"/>
-                </a:solidFill>
-                <a:latin typeface="Arial"/>
-              </a:defRPr>
-            </a:pPr>
-            <a:r>
-              <a:t>Beyond 30 (B30) cities show rapid, compounding folio registration growth,</a:t>
-            </a:r>
-          </a:p>
-          <a:p>
-            <a:pPr>
-              <a:spcAft>
-                <a:spcPts val="800"/>
-              </a:spcAft>
-              <a:defRPr sz="1500">
-                <a:solidFill>
-                  <a:srgbClr val="FFFFFF"/>
-                </a:solidFill>
-                <a:latin typeface="Arial"/>
-              </a:defRPr>
-            </a:pPr>
-            <a:r>
-              <a:t>    highlighting the geographical expansion of mutual fund penetration in India.</a:t>
+            <a:pPr marL="742950" lvl="1" indent="-285750">
+              <a:spcAft>
+                <a:spcPts val="800"/>
+              </a:spcAft>
+              <a:buFont typeface="Arial" panose="020B0604020202020204" pitchFamily="34" charset="0"/>
+              <a:buChar char="•"/>
+              <a:defRPr sz="1500">
+                <a:solidFill>
+                  <a:srgbClr val="FFFFFF"/>
+                </a:solidFill>
+                <a:latin typeface="Arial" panose="020B0604020202020204"/>
+              </a:defRPr>
+            </a:pPr>
+            <a:r>
+              <a:t>Beyond 30 (B30) cities show rapid, compounding folio registration growth, highlighting the geographical expansion of mutual fund penetration in India.</a:t>
             </a:r>
           </a:p>
         </p:txBody>
@@ -4892,7 +4865,7 @@
 </file>
 
 <file path=ppt/slides/slide7.xml><?xml version="1.0" encoding="utf-8"?>
-<p:sld xmlns:a="http://schemas.openxmlformats.org/drawingml/2006/main" xmlns:p="http://schemas.openxmlformats.org/presentationml/2006/main" xmlns:r="http://schemas.openxmlformats.org/officeDocument/2006/relationships">
+<p:sld xmlns:a="http://schemas.openxmlformats.org/drawingml/2006/main" xmlns:r="http://schemas.openxmlformats.org/officeDocument/2006/relationships" xmlns:p="http://schemas.openxmlformats.org/presentationml/2006/main">
   <p:cSld>
     <p:bg>
       <p:bgPr>
@@ -4936,7 +4909,7 @@
                 <a:solidFill>
                   <a:srgbClr val="818CF8"/>
                 </a:solidFill>
-                <a:latin typeface="Arial"/>
+                <a:latin typeface="Arial" panose="020B0604020202020204"/>
               </a:defRPr>
             </a:pPr>
             <a:r>
@@ -4954,7 +4927,7 @@
         <p:spPr>
           <a:xfrm>
             <a:off x="457200" y="1188720"/>
-            <a:ext cx="8229600" cy="3474720"/>
+            <a:ext cx="8229600" cy="3220085"/>
           </a:xfrm>
           <a:prstGeom prst="rect">
             <a:avLst/>
@@ -4975,7 +4948,7 @@
                 <a:solidFill>
                   <a:srgbClr val="FFFFFF"/>
                 </a:solidFill>
-                <a:latin typeface="Arial"/>
+                <a:latin typeface="Arial" panose="020B0604020202020204"/>
               </a:defRPr>
             </a:pPr>
             <a:r>
@@ -4983,15 +4956,17 @@
             </a:r>
           </a:p>
           <a:p>
-            <a:pPr>
-              <a:spcAft>
-                <a:spcPts val="800"/>
-              </a:spcAft>
-              <a:defRPr sz="1500">
-                <a:solidFill>
-                  <a:srgbClr val="FFFFFF"/>
-                </a:solidFill>
-                <a:latin typeface="Arial"/>
+            <a:pPr marL="285750" indent="-285750">
+              <a:spcAft>
+                <a:spcPts val="800"/>
+              </a:spcAft>
+              <a:buFont typeface="Arial" panose="020B0604020202020204" pitchFamily="34" charset="0"/>
+              <a:buChar char="•"/>
+              <a:defRPr sz="1500">
+                <a:solidFill>
+                  <a:srgbClr val="FFFFFF"/>
+                </a:solidFill>
+                <a:latin typeface="Arial" panose="020B0604020202020204"/>
               </a:defRPr>
             </a:pPr>
             <a:r>
@@ -4999,15 +4974,17 @@
             </a:r>
           </a:p>
           <a:p>
-            <a:pPr lvl="1">
-              <a:spcAft>
-                <a:spcPts val="800"/>
-              </a:spcAft>
-              <a:defRPr sz="1500">
-                <a:solidFill>
-                  <a:srgbClr val="FFFFFF"/>
-                </a:solidFill>
-                <a:latin typeface="Arial"/>
+            <a:pPr marL="742950" lvl="1" indent="-285750">
+              <a:spcAft>
+                <a:spcPts val="800"/>
+              </a:spcAft>
+              <a:buFont typeface="Arial" panose="020B0604020202020204" pitchFamily="34" charset="0"/>
+              <a:buChar char="•"/>
+              <a:defRPr sz="1500">
+                <a:solidFill>
+                  <a:srgbClr val="FFFFFF"/>
+                </a:solidFill>
+                <a:latin typeface="Arial" panose="020B0604020202020204"/>
               </a:defRPr>
             </a:pPr>
             <a:r>
@@ -5015,15 +4992,17 @@
             </a:r>
           </a:p>
           <a:p>
-            <a:pPr lvl="1">
-              <a:spcAft>
-                <a:spcPts val="800"/>
-              </a:spcAft>
-              <a:defRPr sz="1500">
-                <a:solidFill>
-                  <a:srgbClr val="FFFFFF"/>
-                </a:solidFill>
-                <a:latin typeface="Arial"/>
+            <a:pPr marL="742950" lvl="1" indent="-285750">
+              <a:spcAft>
+                <a:spcPts val="800"/>
+              </a:spcAft>
+              <a:buFont typeface="Arial" panose="020B0604020202020204" pitchFamily="34" charset="0"/>
+              <a:buChar char="•"/>
+              <a:defRPr sz="1500">
+                <a:solidFill>
+                  <a:srgbClr val="FFFFFF"/>
+                </a:solidFill>
+                <a:latin typeface="Arial" panose="020B0604020202020204"/>
               </a:defRPr>
             </a:pPr>
             <a:r>
@@ -5031,15 +5010,17 @@
             </a:r>
           </a:p>
           <a:p>
-            <a:pPr>
-              <a:spcAft>
-                <a:spcPts val="800"/>
-              </a:spcAft>
-              <a:defRPr sz="1500">
-                <a:solidFill>
-                  <a:srgbClr val="FFFFFF"/>
-                </a:solidFill>
-                <a:latin typeface="Arial"/>
+            <a:pPr marL="285750" indent="-285750">
+              <a:spcAft>
+                <a:spcPts val="800"/>
+              </a:spcAft>
+              <a:buFont typeface="Arial" panose="020B0604020202020204" pitchFamily="34" charset="0"/>
+              <a:buChar char="•"/>
+              <a:defRPr sz="1500">
+                <a:solidFill>
+                  <a:srgbClr val="FFFFFF"/>
+                </a:solidFill>
+                <a:latin typeface="Arial" panose="020B0604020202020204"/>
               </a:defRPr>
             </a:pPr>
             <a:r>
@@ -5047,15 +5028,17 @@
             </a:r>
           </a:p>
           <a:p>
-            <a:pPr lvl="1">
-              <a:spcAft>
-                <a:spcPts val="800"/>
-              </a:spcAft>
-              <a:defRPr sz="1500">
-                <a:solidFill>
-                  <a:srgbClr val="FFFFFF"/>
-                </a:solidFill>
-                <a:latin typeface="Arial"/>
+            <a:pPr marL="742950" lvl="1" indent="-285750">
+              <a:spcAft>
+                <a:spcPts val="800"/>
+              </a:spcAft>
+              <a:buFont typeface="Arial" panose="020B0604020202020204" pitchFamily="34" charset="0"/>
+              <a:buChar char="•"/>
+              <a:defRPr sz="1500">
+                <a:solidFill>
+                  <a:srgbClr val="FFFFFF"/>
+                </a:solidFill>
+                <a:latin typeface="Arial" panose="020B0604020202020204"/>
               </a:defRPr>
             </a:pPr>
             <a:r>
@@ -5063,15 +5046,17 @@
             </a:r>
           </a:p>
           <a:p>
-            <a:pPr lvl="1">
-              <a:spcAft>
-                <a:spcPts val="800"/>
-              </a:spcAft>
-              <a:defRPr sz="1500">
-                <a:solidFill>
-                  <a:srgbClr val="FFFFFF"/>
-                </a:solidFill>
-                <a:latin typeface="Arial"/>
+            <a:pPr marL="742950" lvl="1" indent="-285750">
+              <a:spcAft>
+                <a:spcPts val="800"/>
+              </a:spcAft>
+              <a:buFont typeface="Arial" panose="020B0604020202020204" pitchFamily="34" charset="0"/>
+              <a:buChar char="•"/>
+              <a:defRPr sz="1500">
+                <a:solidFill>
+                  <a:srgbClr val="FFFFFF"/>
+                </a:solidFill>
+                <a:latin typeface="Arial" panose="020B0604020202020204"/>
               </a:defRPr>
             </a:pPr>
             <a:r>
@@ -5079,15 +5064,17 @@
             </a:r>
           </a:p>
           <a:p>
-            <a:pPr>
-              <a:spcAft>
-                <a:spcPts val="800"/>
-              </a:spcAft>
-              <a:defRPr sz="1500">
-                <a:solidFill>
-                  <a:srgbClr val="FFFFFF"/>
-                </a:solidFill>
-                <a:latin typeface="Arial"/>
+            <a:pPr marL="285750" indent="-285750">
+              <a:spcAft>
+                <a:spcPts val="800"/>
+              </a:spcAft>
+              <a:buFont typeface="Arial" panose="020B0604020202020204" pitchFamily="34" charset="0"/>
+              <a:buChar char="•"/>
+              <a:defRPr sz="1500">
+                <a:solidFill>
+                  <a:srgbClr val="FFFFFF"/>
+                </a:solidFill>
+                <a:latin typeface="Arial" panose="020B0604020202020204"/>
               </a:defRPr>
             </a:pPr>
             <a:r>
@@ -5095,15 +5082,17 @@
             </a:r>
           </a:p>
           <a:p>
-            <a:pPr lvl="1">
-              <a:spcAft>
-                <a:spcPts val="800"/>
-              </a:spcAft>
-              <a:defRPr sz="1500">
-                <a:solidFill>
-                  <a:srgbClr val="FFFFFF"/>
-                </a:solidFill>
-                <a:latin typeface="Arial"/>
+            <a:pPr marL="742950" lvl="1" indent="-285750">
+              <a:spcAft>
+                <a:spcPts val="800"/>
+              </a:spcAft>
+              <a:buFont typeface="Arial" panose="020B0604020202020204" pitchFamily="34" charset="0"/>
+              <a:buChar char="•"/>
+              <a:defRPr sz="1500">
+                <a:solidFill>
+                  <a:srgbClr val="FFFFFF"/>
+                </a:solidFill>
+                <a:latin typeface="Arial" panose="020B0604020202020204"/>
               </a:defRPr>
             </a:pPr>
             <a:r>
@@ -5121,7 +5110,7 @@
 </file>
 
 <file path=ppt/slides/slide8.xml><?xml version="1.0" encoding="utf-8"?>
-<p:sld xmlns:a="http://schemas.openxmlformats.org/drawingml/2006/main" xmlns:p="http://schemas.openxmlformats.org/presentationml/2006/main" xmlns:r="http://schemas.openxmlformats.org/officeDocument/2006/relationships">
+<p:sld xmlns:a="http://schemas.openxmlformats.org/drawingml/2006/main" xmlns:r="http://schemas.openxmlformats.org/officeDocument/2006/relationships" xmlns:p="http://schemas.openxmlformats.org/presentationml/2006/main">
   <p:cSld>
     <p:bg>
       <p:bgPr>
@@ -5165,7 +5154,7 @@
                 <a:solidFill>
                   <a:srgbClr val="818CF8"/>
                 </a:solidFill>
-                <a:latin typeface="Arial"/>
+                <a:latin typeface="Arial" panose="020B0604020202020204"/>
               </a:defRPr>
             </a:pPr>
             <a:r>
@@ -5204,7 +5193,7 @@
                 <a:solidFill>
                   <a:srgbClr val="FFFFFF"/>
                 </a:solidFill>
-                <a:latin typeface="Arial"/>
+                <a:latin typeface="Arial" panose="020B0604020202020204"/>
               </a:defRPr>
             </a:pPr>
             <a:r>
@@ -5220,7 +5209,7 @@
                 <a:solidFill>
                   <a:srgbClr val="FFFFFF"/>
                 </a:solidFill>
-                <a:latin typeface="Arial"/>
+                <a:latin typeface="Arial" panose="020B0604020202020204"/>
               </a:defRPr>
             </a:pPr>
             <a:r>
@@ -5236,7 +5225,7 @@
                 <a:solidFill>
                   <a:srgbClr val="FFFFFF"/>
                 </a:solidFill>
-                <a:latin typeface="Arial"/>
+                <a:latin typeface="Arial" panose="020B0604020202020204"/>
               </a:defRPr>
             </a:pPr>
             <a:r>
@@ -5252,7 +5241,7 @@
                 <a:solidFill>
                   <a:srgbClr val="FFFFFF"/>
                 </a:solidFill>
-                <a:latin typeface="Arial"/>
+                <a:latin typeface="Arial" panose="020B0604020202020204"/>
               </a:defRPr>
             </a:pPr>
             <a:r>
@@ -5268,7 +5257,7 @@
                 <a:solidFill>
                   <a:srgbClr val="FFFFFF"/>
                 </a:solidFill>
-                <a:latin typeface="Arial"/>
+                <a:latin typeface="Arial" panose="020B0604020202020204"/>
               </a:defRPr>
             </a:pPr>
             <a:r>
@@ -5284,7 +5273,7 @@
                 <a:solidFill>
                   <a:srgbClr val="FFFFFF"/>
                 </a:solidFill>
-                <a:latin typeface="Arial"/>
+                <a:latin typeface="Arial" panose="020B0604020202020204"/>
               </a:defRPr>
             </a:pPr>
             <a:r>
@@ -5300,7 +5289,7 @@
                 <a:solidFill>
                   <a:srgbClr val="FFFFFF"/>
                 </a:solidFill>
-                <a:latin typeface="Arial"/>
+                <a:latin typeface="Arial" panose="020B0604020202020204"/>
               </a:defRPr>
             </a:pPr>
             <a:r>
@@ -5316,7 +5305,7 @@
                 <a:solidFill>
                   <a:srgbClr val="FFFFFF"/>
                 </a:solidFill>
-                <a:latin typeface="Arial"/>
+                <a:latin typeface="Arial" panose="020B0604020202020204"/>
               </a:defRPr>
             </a:pPr>
             <a:r>
@@ -5332,7 +5321,7 @@
                 <a:solidFill>
                   <a:srgbClr val="FFFFFF"/>
                 </a:solidFill>
-                <a:latin typeface="Arial"/>
+                <a:latin typeface="Arial" panose="020B0604020202020204"/>
               </a:defRPr>
             </a:pPr>
             <a:r>
@@ -5350,7 +5339,7 @@
 </file>
 
 <file path=ppt/slides/slide9.xml><?xml version="1.0" encoding="utf-8"?>
-<p:sld xmlns:a="http://schemas.openxmlformats.org/drawingml/2006/main" xmlns:p="http://schemas.openxmlformats.org/presentationml/2006/main" xmlns:r="http://schemas.openxmlformats.org/officeDocument/2006/relationships">
+<p:sld xmlns:a="http://schemas.openxmlformats.org/drawingml/2006/main" xmlns:r="http://schemas.openxmlformats.org/officeDocument/2006/relationships" xmlns:p="http://schemas.openxmlformats.org/presentationml/2006/main">
   <p:cSld>
     <p:bg>
       <p:bgPr>
@@ -5394,7 +5383,7 @@
                 <a:solidFill>
                   <a:srgbClr val="818CF8"/>
                 </a:solidFill>
-                <a:latin typeface="Arial"/>
+                <a:latin typeface="Arial" panose="020B0604020202020204"/>
               </a:defRPr>
             </a:pPr>
             <a:r>
@@ -5433,7 +5422,7 @@
                 <a:solidFill>
                   <a:srgbClr val="FFFFFF"/>
                 </a:solidFill>
-                <a:latin typeface="Arial"/>
+                <a:latin typeface="Arial" panose="020B0604020202020204"/>
               </a:defRPr>
             </a:pPr>
             <a:r>
@@ -5449,7 +5438,7 @@
                 <a:solidFill>
                   <a:srgbClr val="FFFFFF"/>
                 </a:solidFill>
-                <a:latin typeface="Arial"/>
+                <a:latin typeface="Arial" panose="020B0604020202020204"/>
               </a:defRPr>
             </a:pPr>
             <a:r>
@@ -5465,7 +5454,7 @@
                 <a:solidFill>
                   <a:srgbClr val="FFFFFF"/>
                 </a:solidFill>
-                <a:latin typeface="Arial"/>
+                <a:latin typeface="Arial" panose="020B0604020202020204"/>
               </a:defRPr>
             </a:pPr>
             <a:r>
@@ -5481,7 +5470,7 @@
                 <a:solidFill>
                   <a:srgbClr val="FFFFFF"/>
                 </a:solidFill>
-                <a:latin typeface="Arial"/>
+                <a:latin typeface="Arial" panose="020B0604020202020204"/>
               </a:defRPr>
             </a:pPr>
             <a:r>
@@ -5497,7 +5486,7 @@
                 <a:solidFill>
                   <a:srgbClr val="FFFFFF"/>
                 </a:solidFill>
-                <a:latin typeface="Arial"/>
+                <a:latin typeface="Arial" panose="020B0604020202020204"/>
               </a:defRPr>
             </a:pPr>
             <a:r>
@@ -5513,7 +5502,7 @@
                 <a:solidFill>
                   <a:srgbClr val="FFFFFF"/>
                 </a:solidFill>
-                <a:latin typeface="Arial"/>
+                <a:latin typeface="Arial" panose="020B0604020202020204"/>
               </a:defRPr>
             </a:pPr>
             <a:r>
@@ -5529,7 +5518,7 @@
                 <a:solidFill>
                   <a:srgbClr val="FFFFFF"/>
                 </a:solidFill>
-                <a:latin typeface="Arial"/>
+                <a:latin typeface="Arial" panose="020B0604020202020204"/>
               </a:defRPr>
             </a:pPr>
             <a:r>
@@ -5545,7 +5534,7 @@
                 <a:solidFill>
                   <a:srgbClr val="FFFFFF"/>
                 </a:solidFill>
-                <a:latin typeface="Arial"/>
+                <a:latin typeface="Arial" panose="020B0604020202020204"/>
               </a:defRPr>
             </a:pPr>
             <a:r>
@@ -5878,6 +5867,10 @@
       </a:style>
     </a:lnDef>
   </a:objectDefaults>
-  <a:extraClrSchemeLst/>
+  <a:extLst>
+    <a:ext uri="{05A4C25C-085E-4340-85A3-A5531E510DB2}">
+      <thm15:themeFamily xmlns:thm15="http://schemas.microsoft.com/office/thememl/2012/main" name="Office Theme" id="{62F939B6-93AF-4DB8-9C6B-D6C7DFDC589F}" vid="{4A3C46E8-61CC-4603-A589-7422A47A8E4A}"/>
+    </a:ext>
+  </a:extLst>
 </a:theme>
 </file>
</xml_diff>